<commit_message>
small updates to slides pvadmin
</commit_message>
<xml_diff>
--- a/slides/PVadmin.pptx
+++ b/slides/PVadmin.pptx
@@ -185,6 +185,98 @@
 </p:presentation>
 </file>
 
+<file path=ppt/revisionInfo.xml><?xml version="1.0" encoding="utf-8"?>
+<p1510:revInfo xmlns:a="http://schemas.openxmlformats.org/drawingml/2006/main" xmlns:r="http://schemas.openxmlformats.org/officeDocument/2006/relationships" xmlns:p1510="http://schemas.microsoft.com/office/powerpoint/2015/10/main">
+  <p1510:revLst>
+    <p1510:client id="{413E5923-914B-E029-1A36-41B1AF908270}" v="2" dt="2026-09-08T16:39:48.138"/>
+    <p1510:client id="{F3E8BA9E-F952-8FB8-444E-56408DCA671F}" v="58" dt="2026-09-09T06:36:53.201"/>
+  </p1510:revLst>
+</p1510:revInfo>
+</file>
+
+<file path=ppt/changesInfos/changesInfo1.xml><?xml version="1.0" encoding="utf-8"?>
+<pc:chgInfo xmlns:a="http://schemas.openxmlformats.org/drawingml/2006/main" xmlns:r="http://schemas.openxmlformats.org/officeDocument/2006/relationships" xmlns:ac="http://schemas.microsoft.com/office/drawing/2013/main/command" xmlns:pc="http://schemas.microsoft.com/office/powerpoint/2013/main/command">
+  <pc:docChgLst>
+    <pc:chgData name="Prasetya, S.W.B. (Wishnu)" userId="S::s.w.b.prasetya@uu.nl::ee0482cf-91c5-406c-9af5-c23fbce206d6" providerId="AD" clId="Web-{F3E8BA9E-F952-8FB8-444E-56408DCA671F}"/>
+    <pc:docChg chg="modSld">
+      <pc:chgData name="Prasetya, S.W.B. (Wishnu)" userId="S::s.w.b.prasetya@uu.nl::ee0482cf-91c5-406c-9af5-c23fbce206d6" providerId="AD" clId="Web-{F3E8BA9E-F952-8FB8-444E-56408DCA671F}" dt="2026-09-09T06:36:52.920" v="54" actId="20577"/>
+      <pc:docMkLst>
+        <pc:docMk/>
+      </pc:docMkLst>
+      <pc:sldChg chg="modSp">
+        <pc:chgData name="Prasetya, S.W.B. (Wishnu)" userId="S::s.w.b.prasetya@uu.nl::ee0482cf-91c5-406c-9af5-c23fbce206d6" providerId="AD" clId="Web-{F3E8BA9E-F952-8FB8-444E-56408DCA671F}" dt="2026-09-09T06:18:15.207" v="2" actId="20577"/>
+        <pc:sldMkLst>
+          <pc:docMk/>
+          <pc:sldMk cId="0" sldId="256"/>
+        </pc:sldMkLst>
+        <pc:spChg chg="mod">
+          <ac:chgData name="Prasetya, S.W.B. (Wishnu)" userId="S::s.w.b.prasetya@uu.nl::ee0482cf-91c5-406c-9af5-c23fbce206d6" providerId="AD" clId="Web-{F3E8BA9E-F952-8FB8-444E-56408DCA671F}" dt="2026-09-09T06:18:15.207" v="2" actId="20577"/>
+          <ac:spMkLst>
+            <pc:docMk/>
+            <pc:sldMk cId="0" sldId="256"/>
+            <ac:spMk id="7171" creationId="{00000000-0000-0000-0000-000000000000}"/>
+          </ac:spMkLst>
+        </pc:spChg>
+      </pc:sldChg>
+      <pc:sldChg chg="modSp">
+        <pc:chgData name="Prasetya, S.W.B. (Wishnu)" userId="S::s.w.b.prasetya@uu.nl::ee0482cf-91c5-406c-9af5-c23fbce206d6" providerId="AD" clId="Web-{F3E8BA9E-F952-8FB8-444E-56408DCA671F}" dt="2026-09-09T06:36:52.920" v="54" actId="20577"/>
+        <pc:sldMkLst>
+          <pc:docMk/>
+          <pc:sldMk cId="0" sldId="257"/>
+        </pc:sldMkLst>
+        <pc:spChg chg="mod">
+          <ac:chgData name="Prasetya, S.W.B. (Wishnu)" userId="S::s.w.b.prasetya@uu.nl::ee0482cf-91c5-406c-9af5-c23fbce206d6" providerId="AD" clId="Web-{F3E8BA9E-F952-8FB8-444E-56408DCA671F}" dt="2026-09-09T06:36:52.920" v="54" actId="20577"/>
+          <ac:spMkLst>
+            <pc:docMk/>
+            <pc:sldMk cId="0" sldId="257"/>
+            <ac:spMk id="10244" creationId="{00000000-0000-0000-0000-000000000000}"/>
+          </ac:spMkLst>
+        </pc:spChg>
+      </pc:sldChg>
+      <pc:sldChg chg="modSp">
+        <pc:chgData name="Prasetya, S.W.B. (Wishnu)" userId="S::s.w.b.prasetya@uu.nl::ee0482cf-91c5-406c-9af5-c23fbce206d6" providerId="AD" clId="Web-{F3E8BA9E-F952-8FB8-444E-56408DCA671F}" dt="2026-09-09T06:35:06.025" v="7" actId="20577"/>
+        <pc:sldMkLst>
+          <pc:docMk/>
+          <pc:sldMk cId="2783060835" sldId="294"/>
+        </pc:sldMkLst>
+        <pc:spChg chg="mod">
+          <ac:chgData name="Prasetya, S.W.B. (Wishnu)" userId="S::s.w.b.prasetya@uu.nl::ee0482cf-91c5-406c-9af5-c23fbce206d6" providerId="AD" clId="Web-{F3E8BA9E-F952-8FB8-444E-56408DCA671F}" dt="2026-09-09T06:35:06.025" v="7" actId="20577"/>
+          <ac:spMkLst>
+            <pc:docMk/>
+            <pc:sldMk cId="2783060835" sldId="294"/>
+            <ac:spMk id="3" creationId="{00000000-0000-0000-0000-000000000000}"/>
+          </ac:spMkLst>
+        </pc:spChg>
+      </pc:sldChg>
+    </pc:docChg>
+  </pc:docChgLst>
+  <pc:docChgLst>
+    <pc:chgData name="Prasetya, S.W.B. (Wishnu)" userId="S::s.w.b.prasetya@uu.nl::ee0482cf-91c5-406c-9af5-c23fbce206d6" providerId="AD" clId="Web-{413E5923-914B-E029-1A36-41B1AF908270}"/>
+    <pc:docChg chg="modSld">
+      <pc:chgData name="Prasetya, S.W.B. (Wishnu)" userId="S::s.w.b.prasetya@uu.nl::ee0482cf-91c5-406c-9af5-c23fbce206d6" providerId="AD" clId="Web-{413E5923-914B-E029-1A36-41B1AF908270}" dt="2026-09-08T16:39:47.669" v="0" actId="20577"/>
+      <pc:docMkLst>
+        <pc:docMk/>
+      </pc:docMkLst>
+      <pc:sldChg chg="modSp">
+        <pc:chgData name="Prasetya, S.W.B. (Wishnu)" userId="S::s.w.b.prasetya@uu.nl::ee0482cf-91c5-406c-9af5-c23fbce206d6" providerId="AD" clId="Web-{413E5923-914B-E029-1A36-41B1AF908270}" dt="2026-09-08T16:39:47.669" v="0" actId="20577"/>
+        <pc:sldMkLst>
+          <pc:docMk/>
+          <pc:sldMk cId="1374567603" sldId="289"/>
+        </pc:sldMkLst>
+        <pc:spChg chg="mod">
+          <ac:chgData name="Prasetya, S.W.B. (Wishnu)" userId="S::s.w.b.prasetya@uu.nl::ee0482cf-91c5-406c-9af5-c23fbce206d6" providerId="AD" clId="Web-{413E5923-914B-E029-1A36-41B1AF908270}" dt="2026-09-08T16:39:47.669" v="0" actId="20577"/>
+          <ac:spMkLst>
+            <pc:docMk/>
+            <pc:sldMk cId="1374567603" sldId="289"/>
+            <ac:spMk id="3" creationId="{00000000-0000-0000-0000-000000000000}"/>
+          </ac:spMkLst>
+        </pc:spChg>
+      </pc:sldChg>
+    </pc:docChg>
+  </pc:docChgLst>
+</pc:chgInfo>
+</file>
+
 <file path=ppt/notesMasters/notesMaster1.xml><?xml version="1.0" encoding="utf-8"?>
 <p:notesMaster xmlns:a="http://schemas.openxmlformats.org/drawingml/2006/main" xmlns:r="http://schemas.openxmlformats.org/officeDocument/2006/relationships" xmlns:p="http://schemas.openxmlformats.org/presentationml/2006/main">
   <p:cSld>
@@ -1971,7 +2063,7 @@
               <a:pPr>
                 <a:defRPr/>
               </a:pPr>
-              <a:t>07-09-2025</a:t>
+              <a:t>8-9-2026</a:t>
             </a:fld>
             <a:endParaRPr lang="nl-NL"/>
           </a:p>
@@ -2174,7 +2266,7 @@
               <a:pPr>
                 <a:defRPr/>
               </a:pPr>
-              <a:t>07-09-2025</a:t>
+              <a:t>8-9-2026</a:t>
             </a:fld>
             <a:endParaRPr lang="nl-NL"/>
           </a:p>
@@ -2374,7 +2466,7 @@
               <a:pPr>
                 <a:defRPr/>
               </a:pPr>
-              <a:t>07-09-2025</a:t>
+              <a:t>8-9-2026</a:t>
             </a:fld>
             <a:endParaRPr lang="nl-NL"/>
           </a:p>
@@ -2620,7 +2712,7 @@
               <a:pPr>
                 <a:defRPr/>
               </a:pPr>
-              <a:t>07-09-2025</a:t>
+              <a:t>8-9-2026</a:t>
             </a:fld>
             <a:endParaRPr lang="nl-NL"/>
           </a:p>
@@ -2969,7 +3061,7 @@
               <a:pPr>
                 <a:defRPr/>
               </a:pPr>
-              <a:t>07-09-2025</a:t>
+              <a:t>8-9-2026</a:t>
             </a:fld>
             <a:endParaRPr lang="nl-NL"/>
           </a:p>
@@ -3462,7 +3554,7 @@
               <a:pPr>
                 <a:defRPr/>
               </a:pPr>
-              <a:t>07-09-2025</a:t>
+              <a:t>8-9-2026</a:t>
             </a:fld>
             <a:endParaRPr lang="nl-NL"/>
           </a:p>
@@ -3894,7 +3986,7 @@
               <a:pPr>
                 <a:defRPr/>
               </a:pPr>
-              <a:t>07-09-2025</a:t>
+              <a:t>8-9-2026</a:t>
             </a:fld>
             <a:endParaRPr lang="nl-NL"/>
           </a:p>
@@ -4043,7 +4135,7 @@
               <a:pPr>
                 <a:defRPr/>
               </a:pPr>
-              <a:t>07-09-2025</a:t>
+              <a:t>8-9-2026</a:t>
             </a:fld>
             <a:endParaRPr lang="nl-NL"/>
           </a:p>
@@ -4186,7 +4278,7 @@
               <a:pPr>
                 <a:defRPr/>
               </a:pPr>
-              <a:t>07-09-2025</a:t>
+              <a:t>8-9-2026</a:t>
             </a:fld>
             <a:endParaRPr lang="nl-NL"/>
           </a:p>
@@ -4730,7 +4822,7 @@
               <a:pPr>
                 <a:defRPr/>
               </a:pPr>
-              <a:t>07-09-2025</a:t>
+              <a:t>8-9-2026</a:t>
             </a:fld>
             <a:endParaRPr lang="nl-NL"/>
           </a:p>
@@ -5260,7 +5352,7 @@
               <a:pPr>
                 <a:defRPr/>
               </a:pPr>
-              <a:t>07-09-2025</a:t>
+              <a:t>8-9-2026</a:t>
             </a:fld>
             <a:endParaRPr lang="nl-NL"/>
           </a:p>
@@ -5632,7 +5724,7 @@
               <a:pPr>
                 <a:defRPr/>
               </a:pPr>
-              <a:t>07-09-2025</a:t>
+              <a:t>8-9-2026</a:t>
             </a:fld>
             <a:endParaRPr lang="nl-NL"/>
           </a:p>
@@ -6180,7 +6272,7 @@
             </a:r>
             <a:r>
               <a:rPr lang="en-US" sz="4400" dirty="0"/>
-              <a:t>25</a:t>
+              <a:t>26</a:t>
             </a:r>
             <a:r>
               <a:rPr sz="4400" dirty="0"/>
@@ -6188,7 +6280,7 @@
             </a:r>
             <a:r>
               <a:rPr lang="en-US" sz="4400" dirty="0"/>
-              <a:t>26</a:t>
+              <a:t>27</a:t>
             </a:r>
             <a:endParaRPr sz="4400" dirty="0"/>
           </a:p>
@@ -6359,10 +6451,71 @@
           </a:xfrm>
         </p:spPr>
         <p:txBody>
-          <a:bodyPr>
+          <a:bodyPr vert="horz" lIns="91440" tIns="45720" rIns="91440" bIns="45720" rtlCol="0" anchor="t">
             <a:noAutofit/>
           </a:bodyPr>
           <a:lstStyle/>
+          <a:p>
+            <a:pPr>
+              <a:lnSpc>
+                <a:spcPct val="80000"/>
+              </a:lnSpc>
+            </a:pPr>
+            <a:r>
+              <a:rPr lang="en-US" b="1" dirty="0">
+                <a:latin typeface="Calibri"/>
+                <a:ea typeface="Calibri"/>
+                <a:cs typeface="Calibri"/>
+                <a:sym typeface="Wingdings" pitchFamily="2" charset="2"/>
+              </a:rPr>
+              <a:t>Lectures</a:t>
+            </a:r>
+            <a:r>
+              <a:rPr lang="en-US" dirty="0">
+                <a:latin typeface="Calibri"/>
+                <a:ea typeface="Calibri"/>
+                <a:cs typeface="Calibri"/>
+                <a:sym typeface="Wingdings" pitchFamily="2" charset="2"/>
+              </a:rPr>
+              <a:t> :  every </a:t>
+            </a:r>
+            <a:r>
+              <a:rPr lang="en-US" dirty="0" err="1">
+                <a:latin typeface="Calibri"/>
+                <a:ea typeface="Calibri"/>
+                <a:cs typeface="Calibri"/>
+                <a:sym typeface="Wingdings" pitchFamily="2" charset="2"/>
+              </a:rPr>
+              <a:t>monday</a:t>
+            </a:r>
+            <a:r>
+              <a:rPr lang="en-US" dirty="0">
+                <a:latin typeface="Calibri"/>
+                <a:ea typeface="Calibri"/>
+                <a:cs typeface="Calibri"/>
+                <a:sym typeface="Wingdings" pitchFamily="2" charset="2"/>
+              </a:rPr>
+              <a:t> and </a:t>
+            </a:r>
+            <a:r>
+              <a:rPr lang="en-US" dirty="0" err="1">
+                <a:latin typeface="Calibri"/>
+                <a:ea typeface="Calibri"/>
+                <a:cs typeface="Calibri"/>
+                <a:sym typeface="Wingdings" pitchFamily="2" charset="2"/>
+              </a:rPr>
+              <a:t>wednesday</a:t>
+            </a:r>
+            <a:r>
+              <a:rPr lang="en-US" dirty="0">
+                <a:latin typeface="Calibri"/>
+                <a:ea typeface="Calibri"/>
+                <a:cs typeface="Calibri"/>
+                <a:sym typeface="Wingdings" pitchFamily="2" charset="2"/>
+              </a:rPr>
+              <a:t>, the first 2hrs of allocated meeting slots.</a:t>
+            </a:r>
+          </a:p>
           <a:p>
             <a:pPr eaLnBrk="1" hangingPunct="1">
               <a:lnSpc>
@@ -6370,118 +6523,49 @@
               </a:lnSpc>
             </a:pPr>
             <a:r>
-              <a:rPr lang="en-US" b="1" dirty="0">
-                <a:latin typeface="Calibri" pitchFamily="34" charset="0"/>
-                <a:cs typeface="Calibri" pitchFamily="34" charset="0"/>
+              <a:rPr lang="en-US" dirty="0">
+                <a:latin typeface="Calibri"/>
+                <a:ea typeface="Calibri"/>
+                <a:cs typeface="Calibri"/>
                 <a:sym typeface="Wingdings" pitchFamily="2" charset="2"/>
               </a:rPr>
-              <a:t>Lectures</a:t>
-            </a:r>
-            <a:r>
-              <a:rPr lang="en-US" dirty="0">
-                <a:latin typeface="Calibri" pitchFamily="34" charset="0"/>
-                <a:cs typeface="Calibri" pitchFamily="34" charset="0"/>
-                <a:sym typeface="Wingdings" pitchFamily="2" charset="2"/>
-              </a:rPr>
-              <a:t> : in the morning 9:00 – 11:00 every </a:t>
+              <a:t> Discussing exercises, doing tutorial, doing/discussing/presenting project: every </a:t>
             </a:r>
             <a:r>
               <a:rPr lang="en-US" dirty="0" err="1">
-                <a:latin typeface="Calibri" pitchFamily="34" charset="0"/>
-                <a:cs typeface="Calibri" pitchFamily="34" charset="0"/>
+                <a:latin typeface="Calibri"/>
+                <a:ea typeface="Calibri"/>
+                <a:cs typeface="Calibri"/>
                 <a:sym typeface="Wingdings" pitchFamily="2" charset="2"/>
               </a:rPr>
               <a:t>monday</a:t>
             </a:r>
             <a:r>
               <a:rPr lang="en-US" dirty="0">
-                <a:latin typeface="Calibri" pitchFamily="34" charset="0"/>
-                <a:cs typeface="Calibri" pitchFamily="34" charset="0"/>
+                <a:latin typeface="Calibri"/>
+                <a:ea typeface="Calibri"/>
+                <a:cs typeface="Calibri"/>
                 <a:sym typeface="Wingdings" pitchFamily="2" charset="2"/>
               </a:rPr>
-              <a:t> and </a:t>
-            </a:r>
-            <a:r>
-              <a:rPr lang="en-US" dirty="0" err="1">
-                <a:latin typeface="Calibri" pitchFamily="34" charset="0"/>
-                <a:cs typeface="Calibri" pitchFamily="34" charset="0"/>
-                <a:sym typeface="Wingdings" pitchFamily="2" charset="2"/>
-              </a:rPr>
-              <a:t>wednesday</a:t>
-            </a:r>
-            <a:r>
-              <a:rPr lang="en-US" dirty="0">
-                <a:latin typeface="Calibri" pitchFamily="34" charset="0"/>
-                <a:cs typeface="Calibri" pitchFamily="34" charset="0"/>
-                <a:sym typeface="Wingdings" pitchFamily="2" charset="2"/>
-              </a:rPr>
-              <a:t>.</a:t>
-            </a:r>
-          </a:p>
-          <a:p>
-            <a:pPr eaLnBrk="1" hangingPunct="1">
-              <a:lnSpc>
-                <a:spcPct val="80000"/>
-              </a:lnSpc>
-            </a:pPr>
-            <a:r>
-              <a:rPr lang="en-US" dirty="0">
-                <a:latin typeface="Calibri" pitchFamily="34" charset="0"/>
-                <a:cs typeface="Calibri" pitchFamily="34" charset="0"/>
-                <a:sym typeface="Wingdings" pitchFamily="2" charset="2"/>
-              </a:rPr>
-              <a:t> Discussing exercises, doing tutorial, doing/discussing/presenting project: 11:00 – 12:45, every </a:t>
-            </a:r>
-            <a:r>
-              <a:rPr lang="en-US" dirty="0" err="1">
-                <a:latin typeface="Calibri" pitchFamily="34" charset="0"/>
-                <a:cs typeface="Calibri" pitchFamily="34" charset="0"/>
-                <a:sym typeface="Wingdings" pitchFamily="2" charset="2"/>
-              </a:rPr>
-              <a:t>monday</a:t>
-            </a:r>
-            <a:r>
-              <a:rPr lang="en-US" dirty="0">
-                <a:latin typeface="Calibri" pitchFamily="34" charset="0"/>
-                <a:cs typeface="Calibri" pitchFamily="34" charset="0"/>
-                <a:sym typeface="Wingdings" pitchFamily="2" charset="2"/>
-              </a:rPr>
-              <a:t> and </a:t>
-            </a:r>
-            <a:r>
-              <a:rPr lang="en-US" dirty="0" err="1">
-                <a:latin typeface="Calibri" pitchFamily="34" charset="0"/>
-                <a:cs typeface="Calibri" pitchFamily="34" charset="0"/>
-                <a:sym typeface="Wingdings" pitchFamily="2" charset="2"/>
-              </a:rPr>
-              <a:t>wednesday</a:t>
-            </a:r>
-            <a:r>
-              <a:rPr lang="en-US" dirty="0">
-                <a:latin typeface="Calibri" pitchFamily="34" charset="0"/>
-                <a:cs typeface="Calibri" pitchFamily="34" charset="0"/>
-                <a:sym typeface="Wingdings" pitchFamily="2" charset="2"/>
-              </a:rPr>
-              <a:t> after lectures.</a:t>
+              <a:t> and wednesday after lectures.</a:t>
             </a:r>
             <a:br>
               <a:rPr lang="en-US" dirty="0">
                 <a:latin typeface="Calibri" pitchFamily="34" charset="0"/>
                 <a:cs typeface="Calibri" pitchFamily="34" charset="0"/>
-                <a:sym typeface="Wingdings" pitchFamily="2" charset="2"/>
               </a:rPr>
             </a:br>
             <a:br>
               <a:rPr lang="en-US" dirty="0">
                 <a:latin typeface="Calibri" pitchFamily="34" charset="0"/>
                 <a:cs typeface="Calibri" pitchFamily="34" charset="0"/>
-                <a:sym typeface="Wingdings" pitchFamily="2" charset="2"/>
               </a:rPr>
             </a:br>
             <a:r>
               <a:rPr lang="en-US" dirty="0">
-                <a:latin typeface="Calibri" pitchFamily="34" charset="0"/>
-                <a:cs typeface="Calibri" pitchFamily="34" charset="0"/>
+                <a:latin typeface="Calibri"/>
+                <a:ea typeface="Calibri"/>
+                <a:cs typeface="Calibri"/>
                 <a:sym typeface="Wingdings" pitchFamily="2" charset="2"/>
               </a:rPr>
               <a:t>We may use some of the exercise-hours for lectures if we get a bit short in time.</a:t>
@@ -6490,7 +6574,6 @@
               <a:rPr lang="en-US" dirty="0">
                 <a:latin typeface="Calibri" pitchFamily="34" charset="0"/>
                 <a:cs typeface="Calibri" pitchFamily="34" charset="0"/>
-                <a:sym typeface="Wingdings" pitchFamily="2" charset="2"/>
               </a:rPr>
             </a:br>
             <a:endParaRPr lang="en-US" dirty="0">
@@ -8483,7 +8566,7 @@
           </a:xfrm>
         </p:spPr>
         <p:txBody>
-          <a:bodyPr>
+          <a:bodyPr vert="horz" lIns="91440" tIns="45720" rIns="91440" bIns="45720" rtlCol="0" anchor="t">
             <a:normAutofit/>
           </a:bodyPr>
           <a:lstStyle/>
@@ -8516,8 +8599,12 @@
           <a:p>
             <a:r>
               <a:rPr lang="en-US" sz="2800" dirty="0"/>
-              <a:t>Is this possible?  </a:t>
-            </a:r>
+              <a:t>Is this possible? ...</a:t>
+            </a:r>
+            <a:endParaRPr lang="en-US" sz="2800" dirty="0">
+              <a:ea typeface="Calibri"/>
+              <a:cs typeface="Calibri"/>
+            </a:endParaRPr>
           </a:p>
         </p:txBody>
       </p:sp>
@@ -9946,7 +10033,7 @@
           </a:xfrm>
         </p:spPr>
         <p:txBody>
-          <a:bodyPr>
+          <a:bodyPr vert="horz" lIns="91440" tIns="45720" rIns="91440" bIns="45720" rtlCol="0" anchor="t">
             <a:normAutofit/>
           </a:bodyPr>
           <a:lstStyle/>
@@ -9967,8 +10054,12 @@
             </a:r>
             <a:r>
               <a:rPr lang="en-US" sz="2400" dirty="0"/>
-              <a:t>: a Hoare-style formalism, LTL, CTL.</a:t>
-            </a:r>
+              <a:t>: a Hoare-style formalism, LTL, CTL, probabilistic.</a:t>
+            </a:r>
+            <a:endParaRPr lang="en-US" sz="2400" dirty="0">
+              <a:ea typeface="Calibri"/>
+              <a:cs typeface="Calibri"/>
+            </a:endParaRPr>
           </a:p>
           <a:p>
             <a:pPr lvl="1"/>

</xml_diff>